<commit_message>
Simplify Luca model to case-brief assumptions only; update board deck and tracker to match
Co-authored-by: JoaoTavarees <JoaoTavarees@users.noreply.github.com>
</commit_message>
<xml_diff>
--- a/luca_chief_of_staff_case/deliverables/Luca_Step2_Financial_Operations_Summary.pptx
+++ b/luca_chief_of_staff_case/deliverables/Luca_Step2_Financial_Operations_Summary.pptx
@@ -123,7 +123,7 @@
           <a:p>
             <a:r>
               <a:rPr sz="1100" b="1"/>
-              <a:t>Monthly revenue, gross profit &amp; EBITDA ($k)</a:t>
+              <a:t>Monthly revenue, gross profit &amp; operating profit ($k)</a:t>
             </a:r>
           </a:p>
         </c:rich>
@@ -363,7 +363,7 @@
               <c:strCache>
                 <c:ptCount val="1"/>
                 <c:pt idx="0">
-                  <c:v>EBITDA</c:v>
+                  <c:v>Operating profit</c:v>
                 </c:pt>
               </c:strCache>
             </c:strRef>
@@ -847,7 +847,7 @@
           <a:p>
             <a:r>
               <a:rPr sz="1000" b="1"/>
-              <a:t>Month-end cash ($M)</a:t>
+              <a:t>Cash position ($M)</a:t>
             </a:r>
           </a:p>
         </c:rich>
@@ -941,40 +941,40 @@
                   <c:v>3.0</c:v>
                 </c:pt>
                 <c:pt idx="1">
-                  <c:v>3.59</c:v>
+                  <c:v>3.86</c:v>
                 </c:pt>
                 <c:pt idx="2">
-                  <c:v>4.12</c:v>
+                  <c:v>4.74</c:v>
                 </c:pt>
                 <c:pt idx="3">
-                  <c:v>4.66</c:v>
+                  <c:v>5.65</c:v>
                 </c:pt>
                 <c:pt idx="4">
-                  <c:v>5.23</c:v>
+                  <c:v>6.61</c:v>
                 </c:pt>
                 <c:pt idx="5">
-                  <c:v>5.83</c:v>
+                  <c:v>7.62</c:v>
                 </c:pt>
                 <c:pt idx="6">
-                  <c:v>6.46</c:v>
+                  <c:v>8.68</c:v>
                 </c:pt>
                 <c:pt idx="7">
-                  <c:v>7.16</c:v>
+                  <c:v>9.82</c:v>
                 </c:pt>
                 <c:pt idx="8">
-                  <c:v>7.9</c:v>
+                  <c:v>11.03</c:v>
                 </c:pt>
                 <c:pt idx="9">
-                  <c:v>8.68</c:v>
+                  <c:v>12.31</c:v>
                 </c:pt>
                 <c:pt idx="10">
-                  <c:v>9.5</c:v>
+                  <c:v>13.67</c:v>
                 </c:pt>
                 <c:pt idx="11">
-                  <c:v>10.38</c:v>
+                  <c:v>15.11</c:v>
                 </c:pt>
                 <c:pt idx="12">
-                  <c:v>11.3</c:v>
+                  <c:v>16.63</c:v>
                 </c:pt>
               </c:numCache>
             </c:numRef>
@@ -1062,284 +1062,40 @@
                   <c:v>3.0</c:v>
                 </c:pt>
                 <c:pt idx="1">
-                  <c:v>4.14</c:v>
+                  <c:v>4.4</c:v>
                 </c:pt>
                 <c:pt idx="2">
-                  <c:v>4.66</c:v>
+                  <c:v>5.29</c:v>
                 </c:pt>
                 <c:pt idx="3">
-                  <c:v>5.2</c:v>
+                  <c:v>6.2</c:v>
                 </c:pt>
                 <c:pt idx="4">
-                  <c:v>5.77</c:v>
+                  <c:v>7.15</c:v>
                 </c:pt>
                 <c:pt idx="5">
-                  <c:v>6.37</c:v>
+                  <c:v>8.16</c:v>
                 </c:pt>
                 <c:pt idx="6">
-                  <c:v>7.0</c:v>
+                  <c:v>9.21</c:v>
                 </c:pt>
                 <c:pt idx="7">
-                  <c:v>7.67</c:v>
+                  <c:v>10.32</c:v>
                 </c:pt>
                 <c:pt idx="8">
-                  <c:v>8.37</c:v>
+                  <c:v>11.5</c:v>
                 </c:pt>
                 <c:pt idx="9">
-                  <c:v>9.12</c:v>
+                  <c:v>12.75</c:v>
                 </c:pt>
                 <c:pt idx="10">
-                  <c:v>9.92</c:v>
+                  <c:v>14.08</c:v>
                 </c:pt>
                 <c:pt idx="11">
-                  <c:v>10.76</c:v>
+                  <c:v>15.48</c:v>
                 </c:pt>
                 <c:pt idx="12">
-                  <c:v>11.66</c:v>
-                </c:pt>
-              </c:numCache>
-            </c:numRef>
-          </c:val>
-          <c:smooth val="0"/>
-        </c:ser>
-        <c:ser>
-          <c:idx val="2"/>
-          <c:order val="2"/>
-          <c:tx>
-            <c:strRef>
-              <c:f>Sheet1!$D$1</c:f>
-              <c:strCache>
-                <c:ptCount val="1"/>
-                <c:pt idx="0">
-                  <c:v>Stress – without loan</c:v>
-                </c:pt>
-              </c:strCache>
-            </c:strRef>
-          </c:tx>
-          <c:spPr>
-            <a:ln w="28575">
-              <a:solidFill>
-                <a:srgbClr val="E86A4A"/>
-              </a:solidFill>
-              <a:prstDash val="dash"/>
-            </a:ln>
-          </c:spPr>
-          <c:marker>
-            <c:symbol val="none"/>
-          </c:marker>
-          <c:cat>
-            <c:strRef>
-              <c:f>Sheet1!$A$2:$A$14</c:f>
-              <c:strCache>
-                <c:ptCount val="13"/>
-                <c:pt idx="0">
-                  <c:v>M0</c:v>
-                </c:pt>
-                <c:pt idx="1">
-                  <c:v>M1</c:v>
-                </c:pt>
-                <c:pt idx="2">
-                  <c:v>M2</c:v>
-                </c:pt>
-                <c:pt idx="3">
-                  <c:v>M3</c:v>
-                </c:pt>
-                <c:pt idx="4">
-                  <c:v>M4</c:v>
-                </c:pt>
-                <c:pt idx="5">
-                  <c:v>M5</c:v>
-                </c:pt>
-                <c:pt idx="6">
-                  <c:v>M6</c:v>
-                </c:pt>
-                <c:pt idx="7">
-                  <c:v>M7</c:v>
-                </c:pt>
-                <c:pt idx="8">
-                  <c:v>M8</c:v>
-                </c:pt>
-                <c:pt idx="9">
-                  <c:v>M9</c:v>
-                </c:pt>
-                <c:pt idx="10">
-                  <c:v>M10</c:v>
-                </c:pt>
-                <c:pt idx="11">
-                  <c:v>M11</c:v>
-                </c:pt>
-                <c:pt idx="12">
-                  <c:v>M12</c:v>
-                </c:pt>
-              </c:strCache>
-            </c:strRef>
-          </c:cat>
-          <c:val>
-            <c:numRef>
-              <c:f>Sheet1!$D$2:$D$14</c:f>
-              <c:numCache>
-                <c:formatCode>General</c:formatCode>
-                <c:ptCount val="13"/>
-                <c:pt idx="0">
-                  <c:v>3.0</c:v>
-                </c:pt>
-                <c:pt idx="1">
-                  <c:v>2.85</c:v>
-                </c:pt>
-                <c:pt idx="2">
-                  <c:v>2.47</c:v>
-                </c:pt>
-                <c:pt idx="3">
-                  <c:v>2.05</c:v>
-                </c:pt>
-                <c:pt idx="4">
-                  <c:v>1.61</c:v>
-                </c:pt>
-                <c:pt idx="5">
-                  <c:v>1.15</c:v>
-                </c:pt>
-                <c:pt idx="6">
-                  <c:v>0.66</c:v>
-                </c:pt>
-                <c:pt idx="7">
-                  <c:v>0.18</c:v>
-                </c:pt>
-                <c:pt idx="8">
-                  <c:v>-0.31</c:v>
-                </c:pt>
-                <c:pt idx="9">
-                  <c:v>-0.82</c:v>
-                </c:pt>
-                <c:pt idx="10">
-                  <c:v>-1.35</c:v>
-                </c:pt>
-                <c:pt idx="11">
-                  <c:v>-1.89</c:v>
-                </c:pt>
-                <c:pt idx="12">
-                  <c:v>-2.44</c:v>
-                </c:pt>
-              </c:numCache>
-            </c:numRef>
-          </c:val>
-          <c:smooth val="0"/>
-        </c:ser>
-        <c:ser>
-          <c:idx val="3"/>
-          <c:order val="3"/>
-          <c:tx>
-            <c:strRef>
-              <c:f>Sheet1!$E$1</c:f>
-              <c:strCache>
-                <c:ptCount val="1"/>
-                <c:pt idx="0">
-                  <c:v>Stress – with loan</c:v>
-                </c:pt>
-              </c:strCache>
-            </c:strRef>
-          </c:tx>
-          <c:spPr>
-            <a:ln w="28575">
-              <a:solidFill>
-                <a:srgbClr val="F59E0B"/>
-              </a:solidFill>
-              <a:prstDash val="dash"/>
-            </a:ln>
-          </c:spPr>
-          <c:marker>
-            <c:symbol val="none"/>
-          </c:marker>
-          <c:cat>
-            <c:strRef>
-              <c:f>Sheet1!$A$2:$A$14</c:f>
-              <c:strCache>
-                <c:ptCount val="13"/>
-                <c:pt idx="0">
-                  <c:v>M0</c:v>
-                </c:pt>
-                <c:pt idx="1">
-                  <c:v>M1</c:v>
-                </c:pt>
-                <c:pt idx="2">
-                  <c:v>M2</c:v>
-                </c:pt>
-                <c:pt idx="3">
-                  <c:v>M3</c:v>
-                </c:pt>
-                <c:pt idx="4">
-                  <c:v>M4</c:v>
-                </c:pt>
-                <c:pt idx="5">
-                  <c:v>M5</c:v>
-                </c:pt>
-                <c:pt idx="6">
-                  <c:v>M6</c:v>
-                </c:pt>
-                <c:pt idx="7">
-                  <c:v>M7</c:v>
-                </c:pt>
-                <c:pt idx="8">
-                  <c:v>M8</c:v>
-                </c:pt>
-                <c:pt idx="9">
-                  <c:v>M9</c:v>
-                </c:pt>
-                <c:pt idx="10">
-                  <c:v>M10</c:v>
-                </c:pt>
-                <c:pt idx="11">
-                  <c:v>M11</c:v>
-                </c:pt>
-                <c:pt idx="12">
-                  <c:v>M12</c:v>
-                </c:pt>
-              </c:strCache>
-            </c:strRef>
-          </c:cat>
-          <c:val>
-            <c:numRef>
-              <c:f>Sheet1!$E$2:$E$14</c:f>
-              <c:numCache>
-                <c:formatCode>General</c:formatCode>
-                <c:ptCount val="13"/>
-                <c:pt idx="0">
-                  <c:v>3.0</c:v>
-                </c:pt>
-                <c:pt idx="1">
-                  <c:v>3.4</c:v>
-                </c:pt>
-                <c:pt idx="2">
-                  <c:v>3.02</c:v>
-                </c:pt>
-                <c:pt idx="3">
-                  <c:v>2.6</c:v>
-                </c:pt>
-                <c:pt idx="4">
-                  <c:v>2.15</c:v>
-                </c:pt>
-                <c:pt idx="5">
-                  <c:v>1.69</c:v>
-                </c:pt>
-                <c:pt idx="6">
-                  <c:v>1.2</c:v>
-                </c:pt>
-                <c:pt idx="7">
-                  <c:v>0.68</c:v>
-                </c:pt>
-                <c:pt idx="8">
-                  <c:v>0.15</c:v>
-                </c:pt>
-                <c:pt idx="9">
-                  <c:v>-0.39</c:v>
-                </c:pt>
-                <c:pt idx="10">
-                  <c:v>-0.94</c:v>
-                </c:pt>
-                <c:pt idx="11">
-                  <c:v>-1.51</c:v>
-                </c:pt>
-                <c:pt idx="12">
-                  <c:v>-2.1</c:v>
+                  <c:v>16.97</c:v>
                 </c:pt>
               </c:numCache>
             </c:numRef>
@@ -4739,7 +4495,7 @@
                 </a:solidFill>
                 <a:latin typeface="Arial"/>
               </a:rPr>
-              <a:t>AI-enabled K–12 learning platform for Latin America</a:t>
+              <a:t>EdTech SaaS for K–12 education in Latin America</a:t>
             </a:r>
           </a:p>
           <a:p>
@@ -4755,7 +4511,7 @@
                 </a:solidFill>
                 <a:latin typeface="Arial"/>
               </a:rPr>
-              <a:t>Curriculum-aligned short video lessons, practice and teacher analytics, sold to schools as SaaS. One of Mexico's fastest-growing EdTechs.</a:t>
+              <a:t>One of the fastest-growing startups in Mexico, selling its learning platform and video content to schools.</a:t>
             </a:r>
           </a:p>
           <a:p>
@@ -4787,7 +4543,7 @@
                 </a:solidFill>
                 <a:latin typeface="Arial"/>
               </a:rPr>
-              <a:t>Post-Series A · $1.5M monthly revenue ($18M ARR run-rate) · growing 6% MoM (≈2× a year)</a:t>
+              <a:t>Post-Series A · $1.5M monthly revenue ($18M a year run-rate) · growing 6% a month</a:t>
             </a:r>
           </a:p>
           <a:p>
@@ -4819,7 +4575,7 @@
                 </a:solidFill>
                 <a:latin typeface="Arial"/>
               </a:rPr>
-              <a:t>Unicorn within 7 years; expand beyond Mexico to the rest of LatAm and then globally.</a:t>
+              <a:t>Reach unicorn status within 7 years and expand globally.</a:t>
             </a:r>
           </a:p>
           <a:p>
@@ -4835,7 +4591,7 @@
                 </a:solidFill>
                 <a:latin typeface="Arial"/>
               </a:rPr>
-              <a:t>MY ROLE AS CHIEF OF STAFF</a:t>
+              <a:t>ROLE OF THE CHIEF OF STAFF</a:t>
             </a:r>
           </a:p>
           <a:p>
@@ -4851,7 +4607,7 @@
                 </a:solidFill>
                 <a:latin typeface="Arial"/>
               </a:rPr>
-              <a:t>Turn the plan into an operating system: financial visibility, scalable processes, disciplined hiring and compliant international operations.</a:t>
+              <a:t>Support that growth with financial insight, scalable systems, strong execution and compliant international operations.</a:t>
             </a:r>
           </a:p>
         </p:txBody>
@@ -5074,7 +4830,7 @@
                 </a:solidFill>
                 <a:latin typeface="Arial"/>
               </a:rPr>
-              <a:t>$25.3M revenue over 12 months; exit ARR run-rate ≈ $34M.</a:t>
+              <a:t>$25.3M over 12 months; annual run-rate ≈ $34M by Month 12.</a:t>
             </a:r>
           </a:p>
         </p:txBody>
@@ -5242,7 +4998,7 @@
                 </a:solidFill>
                 <a:latin typeface="Arial"/>
               </a:rPr>
-              <a:t>54% EBITDA margin, $11.3M cash by M12</a:t>
+              <a:t>54% operating margin; cash $3.0M → $16.6M</a:t>
             </a:r>
           </a:p>
           <a:p>
@@ -5258,7 +5014,7 @@
                 </a:solidFill>
                 <a:latin typeface="Arial"/>
               </a:rPr>
-              <a:t>Every month is cash-positive on the case cost base. Gross margin slips 65% → 60% (≈$712k of gross profit forgone).</a:t>
+              <a:t>Every month is cash-positive. Gross margin slips 65% → 60% (≈$712k of gross profit forgone).</a:t>
             </a:r>
           </a:p>
         </p:txBody>
@@ -5442,7 +5198,7 @@
                 </a:solidFill>
                 <a:latin typeface="Arial"/>
               </a:rPr>
-              <a:t>Leaders first, then juniors. 10 of the 25 go to content production; people cost runs at $121k/month from M6.</a:t>
+              <a:t>Seniors first, then juniors. People cost settles at $121k/month from M6.</a:t>
             </a:r>
           </a:p>
         </p:txBody>
@@ -5610,7 +5366,7 @@
                 </a:solidFill>
                 <a:latin typeface="Arial"/>
               </a:rPr>
-              <a:t>Recommendation: do not draw the €500k term loan</a:t>
+              <a:t>Recommendation: do not take the €500k loan</a:t>
             </a:r>
           </a:p>
           <a:p>
@@ -5626,7 +5382,7 @@
                 </a:solidFill>
                 <a:latin typeface="Arial"/>
               </a:rPr>
-              <a:t>Runway is not the constraint: cash never falls below $3.6M. Negotiate an undrawn USD/MXN standby line for collection shocks instead.</a:t>
+              <a:t>Cash never drops below $3.9M without it. The loan adds interest cost and EUR exposure for no runway benefit.</a:t>
             </a:r>
           </a:p>
         </p:txBody>
@@ -5794,7 +5550,7 @@
                 </a:solidFill>
                 <a:latin typeface="Arial"/>
               </a:rPr>
-              <a:t>Gross margin and cash collections</a:t>
+              <a:t>Gross margin and cash collection</a:t>
             </a:r>
           </a:p>
           <a:p>
@@ -5810,7 +5566,7 @@
                 </a:solidFill>
                 <a:latin typeface="Arial"/>
               </a:rPr>
-              <a:t>Each 1 pt of GM = $28k/month by M12. Receivables absorb $2.0M of cash as schools pay at 45 days.</a:t>
+              <a:t>Each 1 pt of gross margin = $28k/month by M12. The model assumes schools pay in the month invoiced.</a:t>
             </a:r>
           </a:p>
         </p:txBody>
@@ -5950,7 +5706,7 @@
                 </a:solidFill>
                 <a:latin typeface="Arial"/>
               </a:rPr>
-              <a:t>Revenue nearly doubles and every month generates cash; COGS, not headcount, drives cost</a:t>
+              <a:t>Revenue nearly doubles and every month generates cash; cost of revenue, not headcount, drives cost</a:t>
             </a:r>
           </a:p>
         </p:txBody>
@@ -6024,7 +5780,7 @@
                 </a:solidFill>
                 <a:latin typeface="Arial"/>
               </a:rPr>
-              <a:t>Luca · Chief of Staff hiring case · all data fictional   |   Source: Luca_Step1_Financial_Model.xlsx (Base case unless stated)</a:t>
+              <a:t>Luca · Chief of Staff hiring case · all data fictional   |   Source: Luca_Step1_Financial_Model.xlsx (case assumptions; opening cash $3.0M assumed)</a:t>
             </a:r>
           </a:p>
         </p:txBody>
@@ -6224,7 +5980,7 @@
                 </a:solidFill>
                 <a:latin typeface="Arial"/>
               </a:rPr>
-              <a:t>+6% MoM compound · $25.3M over 12 months</a:t>
+              <a:t>+6% a month, compounding · $25.3M over 12 months</a:t>
             </a:r>
           </a:p>
         </p:txBody>
@@ -6385,7 +6141,7 @@
                 </a:solidFill>
                 <a:latin typeface="Arial"/>
               </a:rPr>
-              <a:t>Linear compression · $712k gross profit lost vs. flat 65%</a:t>
+              <a:t>Equal monthly steps · $712k gross profit lost vs. flat 65%</a:t>
             </a:r>
           </a:p>
         </p:txBody>
@@ -6546,7 +6302,7 @@
                 </a:solidFill>
                 <a:latin typeface="Arial"/>
               </a:rPr>
-              <a:t>Free cash flow +$593k (M1) → +$926k (M12)</a:t>
+              <a:t>Cash generated: +$857k (M1) → +$1,522k (M12)</a:t>
             </a:r>
           </a:p>
         </p:txBody>
@@ -6691,7 +6447,7 @@
                 </a:solidFill>
                 <a:latin typeface="Arial"/>
               </a:rPr>
-              <a:t>Self-funding</a:t>
+              <a:t>Not a constraint</a:t>
             </a:r>
           </a:p>
           <a:p>
@@ -6707,7 +6463,7 @@
                 </a:solidFill>
                 <a:latin typeface="Arial"/>
               </a:rPr>
-              <a:t>Cash $3.0M → $11.3M without loan; $11.7M with it</a:t>
+              <a:t>Cash $3.0M → $16.6M without loan; $17.0M with it</a:t>
             </a:r>
           </a:p>
         </p:txBody>
@@ -6947,7 +6703,7 @@
                           </a:solidFill>
                           <a:latin typeface="Arial"/>
                         </a:rPr>
-                        <a:t>COGS (delivery, hosting, content)</a:t>
+                        <a:t>Cost of revenue</a:t>
                       </a:r>
                     </a:p>
                   </a:txBody>
@@ -7086,7 +6842,7 @@
                           </a:solidFill>
                           <a:latin typeface="Arial"/>
                         </a:rPr>
-                        <a:t>People (salary + 15% benefits + hiring)</a:t>
+                        <a:t>People (salary + benefits + hiring)</a:t>
                       </a:r>
                     </a:p>
                   </a:txBody>
@@ -7225,7 +6981,7 @@
                           </a:solidFill>
                           <a:latin typeface="Arial"/>
                         </a:rPr>
-                        <a:t>Overhead (+15% linear)</a:t>
+                        <a:t>Overhead (+15% over 12m)</a:t>
                       </a:r>
                     </a:p>
                   </a:txBody>
@@ -7537,7 +7293,7 @@
                 </a:solidFill>
                 <a:latin typeface="Arial"/>
               </a:rPr>
-              <a:t>COGS is 82% of all costs</a:t>
+              <a:t>Cost of revenue is 82% of all costs</a:t>
             </a:r>
             <a:r>
               <a:rPr sz="1050" b="0" i="0">
@@ -7546,7 +7302,7 @@
                 </a:solidFill>
                 <a:latin typeface="Arial"/>
               </a:rPr>
-              <a:t> and more than doubles (+117%) as revenue grows and margin compresses. Unit cost of content and delivery is the lever that matters most.</a:t>
+              <a:t> and more than doubles as revenue grows and margin compresses. Unit cost of content and delivery is the lever that matters most.</a:t>
             </a:r>
           </a:p>
           <a:p>
@@ -7571,7 +7327,7 @@
                 </a:solidFill>
                 <a:latin typeface="Arial"/>
               </a:rPr>
-              <a:t>Headcount is a small share of the P&amp;L</a:t>
+              <a:t>Headcount is a small share</a:t>
             </a:r>
             <a:r>
               <a:rPr sz="1050" b="0" i="0">
@@ -7580,7 +7336,7 @@
                 </a:solidFill>
                 <a:latin typeface="Arial"/>
               </a:rPr>
-              <a:t>: the 25 hires cost $1.35M in year 1. They are spread over M1–M6, so people cost peaks in M6 ($139k) and then stays flat.</a:t>
+              <a:t>: the 25 hires cost $1.35M in year 1. People cost peaks in M6 ($139k, the last month with hiring fees), then stays flat.</a:t>
             </a:r>
           </a:p>
           <a:p>
@@ -7605,7 +7361,7 @@
                 </a:solidFill>
                 <a:latin typeface="Arial"/>
               </a:rPr>
-              <a:t>Cash conversion ≈ 61% of EBITDA</a:t>
+              <a:t>Large safety margin</a:t>
             </a:r>
             <a:r>
               <a:rPr sz="1050" b="0" i="0">
@@ -7614,7 +7370,7 @@
                 </a:solidFill>
                 <a:latin typeface="Arial"/>
               </a:rPr>
-              <a:t>: $4.1M corporate tax (30%) and $2.0M of receivables build-up are the biggest uses of cash.</a:t>
+              <a:t>: costs outside cost of revenue are only ≈$187k/month, so revenue would have to fall below ≈$0.31M/month before Luca burns cash.</a:t>
             </a:r>
           </a:p>
         </p:txBody>
@@ -7754,7 +7510,7 @@
                 </a:solidFill>
                 <a:latin typeface="Arial"/>
               </a:rPr>
-              <a:t>25 hires front-loaded to M1–M3: leaders first, then juniors where production is constrained</a:t>
+              <a:t>25 hires front-loaded to M1–M3: seniors first, then juniors where production is constrained</a:t>
             </a:r>
           </a:p>
         </p:txBody>
@@ -8027,7 +7783,7 @@
                 </a:solidFill>
                 <a:latin typeface="Arial"/>
               </a:rPr>
-              <a:t> to set up processes and onboard the juniors who follow.</a:t>
+              <a:t> so they can set up processes and onboard the juniors who follow.</a:t>
             </a:r>
           </a:p>
           <a:p>
@@ -8061,7 +7817,7 @@
                 </a:solidFill>
                 <a:latin typeface="Arial"/>
               </a:rPr>
-              <a:t> is the most we can onboard well; it slows to 3 a month once M4 leaders are in.</a:t>
+              <a:t> at most, so each new person can be onboarded properly; it slows to 3 a month in M5–M6.</a:t>
             </a:r>
           </a:p>
           <a:p>
@@ -8095,7 +7851,7 @@
                 </a:solidFill>
                 <a:latin typeface="Arial"/>
               </a:rPr>
-              <a:t> keeps the average cost at $4.8k per head and creates a pipeline for promotions.</a:t>
+              <a:t> keeps the average cost at $4.8k per head and builds a bench for promotion.</a:t>
             </a:r>
           </a:p>
         </p:txBody>
@@ -8110,7 +7866,7 @@
         </p:nvGraphicFramePr>
         <p:xfrm>
           <a:off x="4846320" y="1463040"/>
-          <a:ext cx="6903719" cy="3566160"/>
+          <a:ext cx="6903720" cy="3566160"/>
         </p:xfrm>
         <a:graphic>
           <a:graphicData uri="http://schemas.openxmlformats.org/drawingml/2006/table">
@@ -8119,10 +7875,9 @@
                 <a:tableStyleId>{5C22544A-7EE6-4342-B048-85BDC9FD1C3A}</a:tableStyleId>
               </a:tblPr>
               <a:tblGrid>
-                <a:gridCol w="1600200"/>
-                <a:gridCol w="868680"/>
-                <a:gridCol w="685800"/>
-                <a:gridCol w="3749039"/>
+                <a:gridCol w="1737360"/>
+                <a:gridCol w="960120"/>
+                <a:gridCol w="4206240"/>
               </a:tblGrid>
               <a:tr h="509451">
                 <a:tc>
@@ -8131,13 +7886,13 @@
                     <a:lstStyle/>
                     <a:p>
                       <a:r>
-                        <a:rPr sz="950" b="1" i="0">
+                        <a:rPr sz="980" b="1" i="0">
                           <a:solidFill>
                             <a:srgbClr val="FFFFFF"/>
                           </a:solidFill>
                           <a:latin typeface="Arial"/>
                         </a:rPr>
-                        <a:t>Function</a:t>
+                        <a:t>Suggested allocation</a:t>
                       </a:r>
                     </a:p>
                   </a:txBody>
@@ -8153,7 +7908,7 @@
                     <a:lstStyle/>
                     <a:p>
                       <a:r>
-                        <a:rPr sz="950" b="1" i="0">
+                        <a:rPr sz="980" b="1" i="0">
                           <a:solidFill>
                             <a:srgbClr val="FFFFFF"/>
                           </a:solidFill>
@@ -8175,35 +7930,13 @@
                     <a:lstStyle/>
                     <a:p>
                       <a:r>
-                        <a:rPr sz="950" b="1" i="0">
+                        <a:rPr sz="980" b="1" i="0">
                           <a:solidFill>
                             <a:srgbClr val="FFFFFF"/>
                           </a:solidFill>
                           <a:latin typeface="Arial"/>
                         </a:rPr>
-                        <a:t>Timing</a:t>
-                      </a:r>
-                    </a:p>
-                  </a:txBody>
-                  <a:tcPr marL="54864" marR="54864" marT="27432" marB="27432" anchor="ctr">
-                    <a:solidFill>
-                      <a:srgbClr val="1F2A44"/>
-                    </a:solidFill>
-                  </a:tcPr>
-                </a:tc>
-                <a:tc>
-                  <a:txBody>
-                    <a:bodyPr wrap="square"/>
-                    <a:lstStyle/>
-                    <a:p>
-                      <a:r>
-                        <a:rPr sz="950" b="1" i="0">
-                          <a:solidFill>
-                            <a:srgbClr val="FFFFFF"/>
-                          </a:solidFill>
-                          <a:latin typeface="Arial"/>
-                        </a:rPr>
-                        <a:t>Operational capacity it unlocks</a:t>
+                        <a:t>Operational capacity it adds</a:t>
                       </a:r>
                     </a:p>
                   </a:txBody>
@@ -8221,13 +7954,13 @@
                     <a:lstStyle/>
                     <a:p>
                       <a:r>
-                        <a:rPr sz="950" b="1" i="0">
+                        <a:rPr sz="980" b="1" i="0">
                           <a:solidFill>
                             <a:srgbClr val="111827"/>
                           </a:solidFill>
                           <a:latin typeface="Arial"/>
                         </a:rPr>
-                        <a:t>Content &amp; Curriculum</a:t>
+                        <a:t>Content production</a:t>
                       </a:r>
                     </a:p>
                   </a:txBody>
@@ -8243,7 +7976,7 @@
                     <a:lstStyle/>
                     <a:p>
                       <a:r>
-                        <a:rPr sz="950" b="0" i="0">
+                        <a:rPr sz="980" b="0" i="0">
                           <a:solidFill>
                             <a:srgbClr val="111827"/>
                           </a:solidFill>
@@ -8265,35 +7998,13 @@
                     <a:lstStyle/>
                     <a:p>
                       <a:r>
-                        <a:rPr sz="950" b="0" i="0">
+                        <a:rPr sz="980" b="0" i="0">
                           <a:solidFill>
                             <a:srgbClr val="111827"/>
                           </a:solidFill>
                           <a:latin typeface="Arial"/>
                         </a:rPr>
-                        <a:t>M1–M6</a:t>
-                      </a:r>
-                    </a:p>
-                  </a:txBody>
-                  <a:tcPr marL="54864" marR="54864" marT="27432" marB="27432" anchor="ctr">
-                    <a:solidFill>
-                      <a:srgbClr val="FFFFFF"/>
-                    </a:solidFill>
-                  </a:tcPr>
-                </a:tc>
-                <a:tc>
-                  <a:txBody>
-                    <a:bodyPr wrap="square"/>
-                    <a:lstStyle/>
-                    <a:p>
-                      <a:r>
-                        <a:rPr sz="950" b="0" i="0">
-                          <a:solidFill>
-                            <a:srgbClr val="111827"/>
-                          </a:solidFill>
-                          <a:latin typeface="Arial"/>
-                        </a:rPr>
-                        <a:t>Head of Content Ops + Curriculum Lead + 8 creators (script, motion, design, Synthesia, sound, QA) sized to the 30 videos/week target</a:t>
+                        <a:t>Script, design, motion, AI-video and sound capacity toward the 30 videos/week target, plus 2 leads to run the pipeline</a:t>
                       </a:r>
                     </a:p>
                   </a:txBody>
@@ -8311,13 +8022,13 @@
                     <a:lstStyle/>
                     <a:p>
                       <a:r>
-                        <a:rPr sz="950" b="1" i="0">
+                        <a:rPr sz="980" b="1" i="0">
                           <a:solidFill>
                             <a:srgbClr val="111827"/>
                           </a:solidFill>
                           <a:latin typeface="Arial"/>
                         </a:rPr>
-                        <a:t>Sales &amp; Partnerships</a:t>
+                        <a:t>Sales</a:t>
                       </a:r>
                     </a:p>
                   </a:txBody>
@@ -8333,7 +8044,7 @@
                     <a:lstStyle/>
                     <a:p>
                       <a:r>
-                        <a:rPr sz="950" b="0" i="0">
+                        <a:rPr sz="980" b="0" i="0">
                           <a:solidFill>
                             <a:srgbClr val="111827"/>
                           </a:solidFill>
@@ -8355,35 +8066,13 @@
                     <a:lstStyle/>
                     <a:p>
                       <a:r>
-                        <a:rPr sz="950" b="0" i="0">
+                        <a:rPr sz="980" b="0" i="0">
                           <a:solidFill>
                             <a:srgbClr val="111827"/>
                           </a:solidFill>
                           <a:latin typeface="Arial"/>
                         </a:rPr>
-                        <a:t>M1–M4</a:t>
-                      </a:r>
-                    </a:p>
-                  </a:txBody>
-                  <a:tcPr marL="54864" marR="54864" marT="27432" marB="27432" anchor="ctr">
-                    <a:solidFill>
-                      <a:srgbClr val="F3F4F6"/>
-                    </a:solidFill>
-                  </a:tcPr>
-                </a:tc>
-                <a:tc>
-                  <a:txBody>
-                    <a:bodyPr wrap="square"/>
-                    <a:lstStyle/>
-                    <a:p>
-                      <a:r>
-                        <a:rPr sz="950" b="0" i="0">
-                          <a:solidFill>
-                            <a:srgbClr val="111827"/>
-                          </a:solidFill>
-                          <a:latin typeface="Arial"/>
-                        </a:rPr>
-                        <a:t>2 AEs (Mexico + first expansion market) + 2 SDRs to keep up 6% MoM new-logo growth</a:t>
+                        <a:t>New-school pipeline and closing to sustain 6% monthly growth</a:t>
                       </a:r>
                     </a:p>
                   </a:txBody>
@@ -8401,13 +8090,13 @@
                     <a:lstStyle/>
                     <a:p>
                       <a:r>
-                        <a:rPr sz="950" b="1" i="0">
+                        <a:rPr sz="980" b="1" i="0">
                           <a:solidFill>
                             <a:srgbClr val="111827"/>
                           </a:solidFill>
                           <a:latin typeface="Arial"/>
                         </a:rPr>
-                        <a:t>Customer Success</a:t>
+                        <a:t>Customer success</a:t>
                       </a:r>
                     </a:p>
                   </a:txBody>
@@ -8423,7 +8112,7 @@
                     <a:lstStyle/>
                     <a:p>
                       <a:r>
-                        <a:rPr sz="950" b="0" i="0">
+                        <a:rPr sz="980" b="0" i="0">
                           <a:solidFill>
                             <a:srgbClr val="111827"/>
                           </a:solidFill>
@@ -8445,35 +8134,13 @@
                     <a:lstStyle/>
                     <a:p>
                       <a:r>
-                        <a:rPr sz="950" b="0" i="0">
+                        <a:rPr sz="980" b="0" i="0">
                           <a:solidFill>
                             <a:srgbClr val="111827"/>
                           </a:solidFill>
                           <a:latin typeface="Arial"/>
                         </a:rPr>
-                        <a:t>M2–M6</a:t>
-                      </a:r>
-                    </a:p>
-                  </a:txBody>
-                  <a:tcPr marL="54864" marR="54864" marT="27432" marB="27432" anchor="ctr">
-                    <a:solidFill>
-                      <a:srgbClr val="FFFFFF"/>
-                    </a:solidFill>
-                  </a:tcPr>
-                </a:tc>
-                <a:tc>
-                  <a:txBody>
-                    <a:bodyPr wrap="square"/>
-                    <a:lstStyle/>
-                    <a:p>
-                      <a:r>
-                        <a:rPr sz="950" b="0" i="0">
-                          <a:solidFill>
-                            <a:srgbClr val="111827"/>
-                          </a:solidFill>
-                          <a:latin typeface="Arial"/>
-                        </a:rPr>
-                        <a:t>Head of CS + 4 associates / implementation: onboarding and renewals keep pace as the school base roughly doubles</a:t>
+                        <a:t>Onboarding and renewals as the customer base roughly doubles</a:t>
                       </a:r>
                     </a:p>
                   </a:txBody>
@@ -8491,13 +8158,13 @@
                     <a:lstStyle/>
                     <a:p>
                       <a:r>
-                        <a:rPr sz="950" b="1" i="0">
+                        <a:rPr sz="980" b="1" i="0">
                           <a:solidFill>
                             <a:srgbClr val="111827"/>
                           </a:solidFill>
                           <a:latin typeface="Arial"/>
                         </a:rPr>
-                        <a:t>Product &amp; Engineering</a:t>
+                        <a:t>Product &amp; engineering</a:t>
                       </a:r>
                     </a:p>
                   </a:txBody>
@@ -8513,7 +8180,7 @@
                     <a:lstStyle/>
                     <a:p>
                       <a:r>
-                        <a:rPr sz="950" b="0" i="0">
+                        <a:rPr sz="980" b="0" i="0">
                           <a:solidFill>
                             <a:srgbClr val="111827"/>
                           </a:solidFill>
@@ -8535,35 +8202,13 @@
                     <a:lstStyle/>
                     <a:p>
                       <a:r>
-                        <a:rPr sz="950" b="0" i="0">
+                        <a:rPr sz="980" b="0" i="0">
                           <a:solidFill>
                             <a:srgbClr val="111827"/>
                           </a:solidFill>
                           <a:latin typeface="Arial"/>
                         </a:rPr>
-                        <a:t>M1–M5</a:t>
-                      </a:r>
-                    </a:p>
-                  </a:txBody>
-                  <a:tcPr marL="54864" marR="54864" marT="27432" marB="27432" anchor="ctr">
-                    <a:solidFill>
-                      <a:srgbClr val="F3F4F6"/>
-                    </a:solidFill>
-                  </a:tcPr>
-                </a:tc>
-                <a:tc>
-                  <a:txBody>
-                    <a:bodyPr wrap="square"/>
-                    <a:lstStyle/>
-                    <a:p>
-                      <a:r>
-                        <a:rPr sz="950" b="0" i="0">
-                          <a:solidFill>
-                            <a:srgbClr val="111827"/>
-                          </a:solidFill>
-                          <a:latin typeface="Arial"/>
-                        </a:rPr>
-                        <a:t>AI/backend + full-stack engineers + PM: AI content tooling to cut cost per video and protect gross margin</a:t>
+                        <a:t>AI content tooling to cut cost per video and protect gross margin</a:t>
                       </a:r>
                     </a:p>
                   </a:txBody>
@@ -8581,13 +8226,13 @@
                     <a:lstStyle/>
                     <a:p>
                       <a:r>
-                        <a:rPr sz="950" b="1" i="0">
+                        <a:rPr sz="980" b="1" i="0">
                           <a:solidFill>
                             <a:srgbClr val="111827"/>
                           </a:solidFill>
                           <a:latin typeface="Arial"/>
                         </a:rPr>
-                        <a:t>Finance, Legal &amp; Ops</a:t>
+                        <a:t>Finance, legal &amp; ops</a:t>
                       </a:r>
                     </a:p>
                   </a:txBody>
@@ -8603,7 +8248,7 @@
                     <a:lstStyle/>
                     <a:p>
                       <a:r>
-                        <a:rPr sz="950" b="0" i="0">
+                        <a:rPr sz="980" b="0" i="0">
                           <a:solidFill>
                             <a:srgbClr val="111827"/>
                           </a:solidFill>
@@ -8625,35 +8270,13 @@
                     <a:lstStyle/>
                     <a:p>
                       <a:r>
-                        <a:rPr sz="950" b="0" i="0">
+                        <a:rPr sz="980" b="0" i="0">
                           <a:solidFill>
                             <a:srgbClr val="111827"/>
                           </a:solidFill>
                           <a:latin typeface="Arial"/>
                         </a:rPr>
-                        <a:t>M2–M6</a:t>
-                      </a:r>
-                    </a:p>
-                  </a:txBody>
-                  <a:tcPr marL="54864" marR="54864" marT="27432" marB="27432" anchor="ctr">
-                    <a:solidFill>
-                      <a:srgbClr val="FFFFFF"/>
-                    </a:solidFill>
-                  </a:tcPr>
-                </a:tc>
-                <a:tc>
-                  <a:txBody>
-                    <a:bodyPr wrap="square"/>
-                    <a:lstStyle/>
-                    <a:p>
-                      <a:r>
-                        <a:rPr sz="950" b="0" i="0">
-                          <a:solidFill>
-                            <a:srgbClr val="111827"/>
-                          </a:solidFill>
-                          <a:latin typeface="Arial"/>
-                        </a:rPr>
-                        <a:t>FP&amp;A, BI analyst, international legal &amp; compliance: close, cash forecasting, entity set-up</a:t>
+                        <a:t>Monthly close, cash forecasting, international compliance</a:t>
                       </a:r>
                     </a:p>
                   </a:txBody>
@@ -8671,7 +8294,7 @@
                     <a:lstStyle/>
                     <a:p>
                       <a:r>
-                        <a:rPr sz="950" b="1" i="0">
+                        <a:rPr sz="980" b="1" i="0">
                           <a:solidFill>
                             <a:srgbClr val="111827"/>
                           </a:solidFill>
@@ -8693,7 +8316,7 @@
                     <a:lstStyle/>
                     <a:p>
                       <a:r>
-                        <a:rPr sz="950" b="1" i="0">
+                        <a:rPr sz="980" b="1" i="0">
                           <a:solidFill>
                             <a:srgbClr val="111827"/>
                           </a:solidFill>
@@ -8715,35 +8338,13 @@
                     <a:lstStyle/>
                     <a:p>
                       <a:r>
-                        <a:rPr sz="950" b="1" i="0">
+                        <a:rPr sz="980" b="1" i="0">
                           <a:solidFill>
                             <a:srgbClr val="111827"/>
                           </a:solidFill>
                           <a:latin typeface="Arial"/>
                         </a:rPr>
-                        <a:t>M1–M6</a:t>
-                      </a:r>
-                    </a:p>
-                  </a:txBody>
-                  <a:tcPr marL="54864" marR="54864" marT="27432" marB="27432" anchor="ctr">
-                    <a:solidFill>
-                      <a:srgbClr val="F3F4F6"/>
-                    </a:solidFill>
-                  </a:tcPr>
-                </a:tc>
-                <a:tc>
-                  <a:txBody>
-                    <a:bodyPr wrap="square"/>
-                    <a:lstStyle/>
-                    <a:p>
-                      <a:r>
-                        <a:rPr sz="950" b="1" i="0">
-                          <a:solidFill>
-                            <a:srgbClr val="111827"/>
-                          </a:solidFill>
-                          <a:latin typeface="Arial"/>
-                        </a:rPr>
-                        <a:t>New-plan headcount 5 → 25 by M6</a:t>
+                        <a:t>New-hire headcount 5 → 25 by M6</a:t>
                       </a:r>
                     </a:p>
                   </a:txBody>
@@ -9850,7 +9451,7 @@
                 </a:solidFill>
                 <a:latin typeface="Arial"/>
               </a:rPr>
-              <a:t>: role scorecards, structured interviews, weekly pipeline review. Target ≤45 days to hire; 5 roles open at any time.</a:t>
+              <a:t>: role scorecards, structured interviews and a weekly pipeline review to sustain 5 hires a month.</a:t>
             </a:r>
           </a:p>
         </p:txBody>
@@ -9983,7 +9584,7 @@
                 </a:solidFill>
                 <a:latin typeface="Arial"/>
               </a:rPr>
-              <a:t>: every junior gets a senior buddy, and goals are set in week 1.</a:t>
+              <a:t>: every junior gets a senior buddy, with goals set in week 1.</a:t>
             </a:r>
           </a:p>
         </p:txBody>
@@ -10240,7 +9841,7 @@
                 </a:solidFill>
                 <a:latin typeface="Arial"/>
               </a:rPr>
-              <a:t>Collections cadence</a:t>
+              <a:t>Invoicing &amp; collections cadence</a:t>
             </a:r>
             <a:r>
               <a:rPr sz="980" b="0" i="0">
@@ -10249,7 +9850,7 @@
                 </a:solidFill>
                 <a:latin typeface="Arial"/>
               </a:rPr>
-              <a:t>: invoice on day 1, reminders at 30/45/60 days, escalation at 75 days. Receivables are the biggest use of cash.</a:t>
+              <a:t>: the plan assumes schools pay in the month invoiced, so late payments need to be chased early.</a:t>
             </a:r>
           </a:p>
         </p:txBody>
@@ -10504,7 +10105,7 @@
                 </a:solidFill>
                 <a:latin typeface="Arial"/>
               </a:rPr>
-              <a:t>HRIS + payroll</a:t>
+              <a:t>HR &amp; payroll system</a:t>
             </a:r>
             <a:r>
               <a:rPr sz="980" b="0" i="0">
@@ -10513,7 +10114,7 @@
                 </a:solidFill>
                 <a:latin typeface="Arial"/>
               </a:rPr>
-              <a:t> for Mexico; an Employer of Record (EOR) for first hires abroad; ATS to track hiring funnels.</a:t>
+              <a:t> able to onboard 25 people in 6 months, plus an applicant tracking system for the hiring funnel.</a:t>
             </a:r>
           </a:p>
         </p:txBody>
@@ -10637,7 +10238,7 @@
                 </a:solidFill>
                 <a:latin typeface="Arial"/>
               </a:rPr>
-              <a:t>Finance stack</a:t>
+              <a:t>Accounting system</a:t>
             </a:r>
             <a:r>
               <a:rPr sz="980" b="0" i="0">
@@ -10646,7 +10247,7 @@
                 </a:solidFill>
                 <a:latin typeface="Arial"/>
               </a:rPr>
-              <a:t>: accounting/ERP with Mexican e-invoicing (CFDI/SAT) and multi-currency, ready for new entities.</a:t>
+              <a:t> with Mexican e-invoicing and multi-currency, ready for international entities.</a:t>
             </a:r>
           </a:p>
         </p:txBody>
@@ -10770,7 +10371,7 @@
                 </a:solidFill>
                 <a:latin typeface="Arial"/>
               </a:rPr>
-              <a:t>CRM as the revenue source of truth</a:t>
+              <a:t>CRM as the single source of truth</a:t>
             </a:r>
             <a:r>
               <a:rPr sz="980" b="0" i="0">
@@ -10779,7 +10380,7 @@
                 </a:solidFill>
                 <a:latin typeface="Arial"/>
               </a:rPr>
-              <a:t> (pipeline → bookings → billing) feeding a weekly BI dashboard.</a:t>
+              <a:t> for pipeline → contracts → billing, feeding a weekly dashboard.</a:t>
             </a:r>
           </a:p>
         </p:txBody>
@@ -10912,7 +10513,7 @@
                 </a:solidFill>
                 <a:latin typeface="Arial"/>
               </a:rPr>
-              <a:t> with stage SLAs and WIP limits, plus AI tooling (see Execution deck).</a:t>
+              <a:t> with stage deadlines and work-in-progress limits (see Execution deck).</a:t>
             </a:r>
           </a:p>
         </p:txBody>
@@ -11176,7 +10777,7 @@
                 </a:solidFill>
                 <a:latin typeface="Arial"/>
               </a:rPr>
-              <a:t>: hire only against the approved 25-role plan. Any change needs CEO + CoS sign-off and a P&amp;L impact note.</a:t>
+              <a:t>: hire only against the approved 25-role plan; any change needs CEO sign-off and a cost note.</a:t>
             </a:r>
           </a:p>
         </p:txBody>
@@ -11300,7 +10901,7 @@
                 </a:solidFill>
                 <a:latin typeface="Arial"/>
               </a:rPr>
-              <a:t>Delegation-of-authority matrix</a:t>
+              <a:t>Spend approval limits</a:t>
             </a:r>
             <a:r>
               <a:rPr sz="980" b="0" i="0">
@@ -11309,7 +10910,7 @@
                 </a:solidFill>
                 <a:latin typeface="Arial"/>
               </a:rPr>
-              <a:t>: spend approvals by threshold; dual sign-off on payments; monthly vendor review.</a:t>
+              <a:t> by amount, dual sign-off on payments, and a monthly vendor review.</a:t>
             </a:r>
           </a:p>
         </p:txBody>
@@ -11442,7 +11043,7 @@
                 </a:solidFill>
                 <a:latin typeface="Arial"/>
               </a:rPr>
-              <a:t>: track COGS per student and cost per video. If GM is below plan for 2 months, run a cost review.</a:t>
+              <a:t>: track cost per customer and per video. If margin is below plan for 2 months, run a cost review.</a:t>
             </a:r>
           </a:p>
         </p:txBody>
@@ -11575,7 +11176,7 @@
                 </a:solidFill>
                 <a:latin typeface="Arial"/>
               </a:rPr>
-              <a:t>: entity and tax set-up, transfer pricing, data protection for minors (Mexican LFPDPPP, Brazilian LGPD, GDPR).</a:t>
+              <a:t>: entity and tax set-up and data protection for minors before selling outside Mexico.</a:t>
             </a:r>
           </a:p>
         </p:txBody>
@@ -11669,7 +11270,7 @@
                 </a:solidFill>
                 <a:latin typeface="Arial"/>
               </a:rPr>
-              <a:t> CoS runs the operating cadence (weekly leadership KPIs, monthly business review, quarterly board pack). Each function head owns their hiring, budget and SLAs. FP&amp;A (hire #6, M2) owns the model and the 13-week cash view.</a:t>
+              <a:t> the Chief of Staff runs the operating cadence (weekly leadership KPIs, monthly business review, quarterly board pack). Each function head owns their hiring, budget and deadlines.</a:t>
             </a:r>
           </a:p>
         </p:txBody>
@@ -11809,7 +11410,7 @@
                 </a:solidFill>
                 <a:latin typeface="Arial"/>
               </a:rPr>
-              <a:t>Don't draw the €500k loan: it barely moves runway and adds FX risk. Watch margin and collections</a:t>
+              <a:t>Don't take the €500k loan: Luca doesn't need the cash, and it adds cost and FX risk</a:t>
             </a:r>
           </a:p>
         </p:txBody>
@@ -11883,7 +11484,7 @@
                 </a:solidFill>
                 <a:latin typeface="Arial"/>
               </a:rPr>
-              <a:t>Luca · Chief of Staff hiring case · all data fictional   |   Source: Luca_Step1_Financial_Model.xlsx (Base case unless stated); Stress = flat revenue, GM→55%, DSO→90 days + $1.0M/mo existing cost base (illustrative)</a:t>
+              <a:t>Luca · Chief of Staff hiring case · all data fictional   |   Source: Luca_Step1_Financial_Model.xlsx (case assumptions; opening cash $3.0M assumed)</a:t>
             </a:r>
           </a:p>
         </p:txBody>
@@ -12067,7 +11668,7 @@
                 </a:solidFill>
                 <a:latin typeface="Arial"/>
               </a:rPr>
-              <a:t>Decline the €500k term loan as structured; negotiate an undrawn USD/MXN standby facility instead</a:t>
+              <a:t>Decline the loan. Revisit only if a real cash need appears, such as expansion spending in euros.</a:t>
             </a:r>
           </a:p>
         </p:txBody>
@@ -12099,8 +11700,8 @@
           <p:nvPr/>
         </p:nvGraphicFramePr>
         <p:xfrm>
-          <a:off x="3749039" y="2331720"/>
-          <a:ext cx="2468880" cy="1325880"/>
+          <a:off x="3794760" y="2331720"/>
+          <a:ext cx="2423160" cy="1600200"/>
         </p:xfrm>
         <a:graphic>
           <a:graphicData uri="http://schemas.openxmlformats.org/drawingml/2006/table">
@@ -12109,24 +11710,24 @@
                 <a:tableStyleId>{5C22544A-7EE6-4342-B048-85BDC9FD1C3A}</a:tableStyleId>
               </a:tblPr>
               <a:tblGrid>
+                <a:gridCol w="960120"/>
                 <a:gridCol w="731520"/>
-                <a:gridCol w="868680"/>
-                <a:gridCol w="868680"/>
+                <a:gridCol w="731520"/>
               </a:tblGrid>
-              <a:tr h="331470">
+              <a:tr h="320040">
                 <a:tc>
                   <a:txBody>
                     <a:bodyPr wrap="square"/>
                     <a:lstStyle/>
                     <a:p>
                       <a:r>
-                        <a:rPr sz="900" b="1" i="0">
+                        <a:rPr sz="880" b="1" i="0">
                           <a:solidFill>
                             <a:srgbClr val="FFFFFF"/>
                           </a:solidFill>
                           <a:latin typeface="Arial"/>
                         </a:rPr>
-                        <a:t>Runway</a:t>
+                        <a:t>Month 12</a:t>
                       </a:r>
                     </a:p>
                   </a:txBody>
@@ -12143,7 +11744,7 @@
                     <a:p>
                       <a:pPr algn="r"/>
                       <a:r>
-                        <a:rPr sz="900" b="1" i="0">
+                        <a:rPr sz="880" b="1" i="0">
                           <a:solidFill>
                             <a:srgbClr val="FFFFFF"/>
                           </a:solidFill>
@@ -12166,7 +11767,7 @@
                     <a:p>
                       <a:pPr algn="r"/>
                       <a:r>
-                        <a:rPr sz="900" b="1" i="0">
+                        <a:rPr sz="880" b="1" i="0">
                           <a:solidFill>
                             <a:srgbClr val="FFFFFF"/>
                           </a:solidFill>
@@ -12183,20 +11784,20 @@
                   </a:tcPr>
                 </a:tc>
               </a:tr>
-              <a:tr h="331470">
+              <a:tr h="320040">
                 <a:tc>
                   <a:txBody>
                     <a:bodyPr wrap="square"/>
                     <a:lstStyle/>
                     <a:p>
                       <a:r>
-                        <a:rPr sz="900" b="0" i="0">
+                        <a:rPr sz="880" b="0" i="0">
                           <a:solidFill>
                             <a:srgbClr val="111827"/>
                           </a:solidFill>
                           <a:latin typeface="Arial"/>
                         </a:rPr>
-                        <a:t>Base</a:t>
+                        <a:t>Cash</a:t>
                       </a:r>
                     </a:p>
                   </a:txBody>
@@ -12213,13 +11814,13 @@
                     <a:p>
                       <a:pPr algn="r"/>
                       <a:r>
-                        <a:rPr sz="900" b="0" i="0">
+                        <a:rPr sz="880" b="0" i="0">
                           <a:solidFill>
                             <a:srgbClr val="111827"/>
                           </a:solidFill>
                           <a:latin typeface="Arial"/>
                         </a:rPr>
-                        <a:t>Self-funding</a:t>
+                        <a:t>$16.63M</a:t>
                       </a:r>
                     </a:p>
                   </a:txBody>
@@ -12236,13 +11837,13 @@
                     <a:p>
                       <a:pPr algn="r"/>
                       <a:r>
-                        <a:rPr sz="900" b="0" i="0">
+                        <a:rPr sz="880" b="0" i="0">
                           <a:solidFill>
                             <a:srgbClr val="111827"/>
                           </a:solidFill>
                           <a:latin typeface="Arial"/>
                         </a:rPr>
-                        <a:t>Self-funding</a:t>
+                        <a:t>$16.97M</a:t>
                       </a:r>
                     </a:p>
                   </a:txBody>
@@ -12253,20 +11854,20 @@
                   </a:tcPr>
                 </a:tc>
               </a:tr>
-              <a:tr h="331470">
+              <a:tr h="320040">
                 <a:tc>
                   <a:txBody>
                     <a:bodyPr wrap="square"/>
                     <a:lstStyle/>
                     <a:p>
                       <a:r>
-                        <a:rPr sz="900" b="0" i="0">
+                        <a:rPr sz="880" b="0" i="0">
                           <a:solidFill>
                             <a:srgbClr val="111827"/>
                           </a:solidFill>
                           <a:latin typeface="Arial"/>
                         </a:rPr>
-                        <a:t>Downside</a:t>
+                        <a:t>Loan still owed</a:t>
                       </a:r>
                     </a:p>
                   </a:txBody>
@@ -12283,13 +11884,13 @@
                     <a:p>
                       <a:pPr algn="r"/>
                       <a:r>
-                        <a:rPr sz="900" b="0" i="0">
+                        <a:rPr sz="880" b="0" i="0">
                           <a:solidFill>
                             <a:srgbClr val="111827"/>
                           </a:solidFill>
                           <a:latin typeface="Arial"/>
                         </a:rPr>
-                        <a:t>Self-funding</a:t>
+                        <a:t>–</a:t>
                       </a:r>
                     </a:p>
                   </a:txBody>
@@ -12306,13 +11907,13 @@
                     <a:p>
                       <a:pPr algn="r"/>
                       <a:r>
-                        <a:rPr sz="900" b="0" i="0">
+                        <a:rPr sz="880" b="0" i="0">
                           <a:solidFill>
                             <a:srgbClr val="111827"/>
                           </a:solidFill>
                           <a:latin typeface="Arial"/>
                         </a:rPr>
-                        <a:t>Self-funding</a:t>
+                        <a:t>$372k</a:t>
                       </a:r>
                     </a:p>
                   </a:txBody>
@@ -12323,20 +11924,20 @@
                   </a:tcPr>
                 </a:tc>
               </a:tr>
-              <a:tr h="331470">
+              <a:tr h="320040">
                 <a:tc>
                   <a:txBody>
                     <a:bodyPr wrap="square"/>
                     <a:lstStyle/>
                     <a:p>
                       <a:r>
-                        <a:rPr sz="900" b="0" i="0">
+                        <a:rPr sz="880" b="0" i="0">
                           <a:solidFill>
                             <a:srgbClr val="111827"/>
                           </a:solidFill>
                           <a:latin typeface="Arial"/>
                         </a:rPr>
-                        <a:t>Stress</a:t>
+                        <a:t>Cash minus loan</a:t>
                       </a:r>
                     </a:p>
                   </a:txBody>
@@ -12353,13 +11954,13 @@
                     <a:p>
                       <a:pPr algn="r"/>
                       <a:r>
-                        <a:rPr sz="900" b="0" i="0">
+                        <a:rPr sz="880" b="0" i="0">
                           <a:solidFill>
                             <a:srgbClr val="111827"/>
                           </a:solidFill>
                           <a:latin typeface="Arial"/>
                         </a:rPr>
-                        <a:t>7.4 mo</a:t>
+                        <a:t>$16.63M</a:t>
                       </a:r>
                     </a:p>
                   </a:txBody>
@@ -12376,13 +11977,13 @@
                     <a:p>
                       <a:pPr algn="r"/>
                       <a:r>
-                        <a:rPr sz="900" b="0" i="0">
+                        <a:rPr sz="880" b="0" i="0">
                           <a:solidFill>
                             <a:srgbClr val="111827"/>
                           </a:solidFill>
                           <a:latin typeface="Arial"/>
                         </a:rPr>
-                        <a:t>8.3 mo</a:t>
+                        <a:t>$16.60M</a:t>
                       </a:r>
                     </a:p>
                   </a:txBody>
@@ -12393,6 +11994,76 @@
                   </a:tcPr>
                 </a:tc>
               </a:tr>
+              <a:tr h="320040">
+                <a:tc>
+                  <a:txBody>
+                    <a:bodyPr wrap="square"/>
+                    <a:lstStyle/>
+                    <a:p>
+                      <a:r>
+                        <a:rPr sz="880" b="0" i="0">
+                          <a:solidFill>
+                            <a:srgbClr val="111827"/>
+                          </a:solidFill>
+                          <a:latin typeface="Arial"/>
+                        </a:rPr>
+                        <a:t>Lowest cash (12m)</a:t>
+                      </a:r>
+                    </a:p>
+                  </a:txBody>
+                  <a:tcPr marL="54864" marR="54864" marT="27432" marB="27432" anchor="ctr">
+                    <a:solidFill>
+                      <a:srgbClr val="F3F4F6"/>
+                    </a:solidFill>
+                  </a:tcPr>
+                </a:tc>
+                <a:tc>
+                  <a:txBody>
+                    <a:bodyPr wrap="square"/>
+                    <a:lstStyle/>
+                    <a:p>
+                      <a:pPr algn="r"/>
+                      <a:r>
+                        <a:rPr sz="880" b="0" i="0">
+                          <a:solidFill>
+                            <a:srgbClr val="111827"/>
+                          </a:solidFill>
+                          <a:latin typeface="Arial"/>
+                        </a:rPr>
+                        <a:t>$3.86M</a:t>
+                      </a:r>
+                    </a:p>
+                  </a:txBody>
+                  <a:tcPr marL="54864" marR="54864" marT="27432" marB="27432" anchor="ctr">
+                    <a:solidFill>
+                      <a:srgbClr val="F3F4F6"/>
+                    </a:solidFill>
+                  </a:tcPr>
+                </a:tc>
+                <a:tc>
+                  <a:txBody>
+                    <a:bodyPr wrap="square"/>
+                    <a:lstStyle/>
+                    <a:p>
+                      <a:pPr algn="r"/>
+                      <a:r>
+                        <a:rPr sz="880" b="0" i="0">
+                          <a:solidFill>
+                            <a:srgbClr val="111827"/>
+                          </a:solidFill>
+                          <a:latin typeface="Arial"/>
+                        </a:rPr>
+                        <a:t>$4.40M</a:t>
+                      </a:r>
+                    </a:p>
+                  </a:txBody>
+                  <a:tcPr marL="54864" marR="54864" marT="27432" marB="27432" anchor="ctr">
+                    <a:solidFill>
+                      <a:srgbClr val="F3F4F6"/>
+                    </a:solidFill>
+                  </a:tcPr>
+                </a:tc>
+              </a:tr>
             </a:tbl>
           </a:graphicData>
         </a:graphic>
@@ -12405,8 +12076,8 @@
         </p:nvSpPr>
         <p:spPr>
           <a:xfrm>
-            <a:off x="3749039" y="3703320"/>
-            <a:ext cx="2468880" cy="1188720"/>
+            <a:off x="3794760" y="4023360"/>
+            <a:ext cx="2423160" cy="914400"/>
           </a:xfrm>
           <a:prstGeom prst="rect">
             <a:avLst/>
@@ -12431,59 +12102,7 @@
                 </a:solidFill>
                 <a:latin typeface="Arial"/>
               </a:rPr>
-              <a:t>Even under Stress, the loan buys only </a:t>
-            </a:r>
-            <a:r>
-              <a:rPr sz="950" b="1" i="0">
-                <a:solidFill>
-                  <a:srgbClr val="111827"/>
-                </a:solidFill>
-                <a:latin typeface="Arial"/>
-              </a:rPr>
-              <a:t>+0.9 months</a:t>
-            </a:r>
-            <a:r>
-              <a:rPr sz="950" b="0" i="0">
-                <a:solidFill>
-                  <a:srgbClr val="111827"/>
-                </a:solidFill>
-                <a:latin typeface="Arial"/>
-              </a:rPr>
-              <a:t>. It does not fix a structural burn.</a:t>
-            </a:r>
-          </a:p>
-          <a:p>
-            <a:pPr algn="l">
-              <a:spcAft>
-                <a:spcPts val="400"/>
-              </a:spcAft>
-            </a:pPr>
-            <a:r>
-              <a:rPr sz="950" b="0" i="0">
-                <a:solidFill>
-                  <a:srgbClr val="111827"/>
-                </a:solidFill>
-                <a:latin typeface="Arial"/>
-              </a:rPr>
-              <a:t>Base plan can absorb </a:t>
-            </a:r>
-            <a:r>
-              <a:rPr sz="950" b="1" i="0">
-                <a:solidFill>
-                  <a:srgbClr val="111827"/>
-                </a:solidFill>
-                <a:latin typeface="Arial"/>
-              </a:rPr>
-              <a:t>$1.25M/month</a:t>
-            </a:r>
-            <a:r>
-              <a:rPr sz="950" b="0" i="0">
-                <a:solidFill>
-                  <a:srgbClr val="111827"/>
-                </a:solidFill>
-                <a:latin typeface="Arial"/>
-              </a:rPr>
-              <a:t> of extra fixed cost before cash runs out.</a:t>
+              <a:t>The loan adds $550k of cash, about 3% of Month-12 cash, and leaves Luca $31k worse off after interest.</a:t>
             </a:r>
           </a:p>
         </p:txBody>
@@ -12496,8 +12115,8 @@
         </p:nvSpPr>
         <p:spPr>
           <a:xfrm>
-            <a:off x="457200" y="4892040"/>
-            <a:ext cx="5760720" cy="1508760"/>
+            <a:off x="457200" y="4983480"/>
+            <a:ext cx="5760720" cy="1417320"/>
           </a:xfrm>
           <a:prstGeom prst="rect">
             <a:avLst/>
@@ -12540,7 +12159,7 @@
                 </a:solidFill>
                 <a:latin typeface="Arial"/>
               </a:rPr>
-              <a:t> cash never drops below $3.6M without the loan; free cash flow is positive in all 12 months.</a:t>
+              <a:t> Luca generates cash every month. Runway is not limited with or without the loan.</a:t>
             </a:r>
           </a:p>
           <a:p>
@@ -12574,7 +12193,7 @@
                 </a:solidFill>
                 <a:latin typeface="Arial"/>
               </a:rPr>
-              <a:t> $43k interest over 24 months. Net cash at M12 is $21k lower with the loan, and $372k of debt is still owed at M12.</a:t>
+              <a:t> $43k of interest over 24 months ($31k in year 1), with $372k still owed at Month 12.</a:t>
             </a:r>
           </a:p>
           <a:p>
@@ -12608,7 +12227,7 @@
                 </a:solidFill>
                 <a:latin typeface="Arial"/>
               </a:rPr>
-              <a:t> a EUR liability against MXN/USD revenue. A +0.10 move in EUR/USD adds ≈$54k to repayments. Lenders may also impose covenants and reporting.</a:t>
+              <a:t> the debt is in euros, but revenue isn't. If the euro rises by $0.10, repayments cost ≈$54k more.</a:t>
             </a:r>
           </a:p>
           <a:p>
@@ -12642,7 +12261,7 @@
                 </a:solidFill>
                 <a:latin typeface="Arial"/>
               </a:rPr>
-              <a:t> a committed but undrawn line covers the real risk (collection delays) without paying interest. Revisit if we open EUR-cost markets, where EUR debt would be a natural hedge.</a:t>
+              <a:t> not borrowing keeps the balance sheet clean for a future equity round or a better-matched facility.</a:t>
             </a:r>
           </a:p>
         </p:txBody>
@@ -12851,7 +12470,7 @@
                 </a:solidFill>
                 <a:latin typeface="Arial"/>
               </a:rPr>
-              <a:t>Gross margin compression outpacing plan</a:t>
+              <a:t>Gross margin falling faster than plan</a:t>
             </a:r>
           </a:p>
         </p:txBody>
@@ -12884,13 +12503,13 @@
               </a:spcAft>
             </a:pPr>
             <a:r>
-              <a:rPr sz="1050" b="0" i="0">
+              <a:rPr sz="1019" b="0" i="0">
                 <a:solidFill>
                   <a:srgbClr val="111827"/>
                 </a:solidFill>
                 <a:latin typeface="Arial"/>
               </a:rPr>
-              <a:t>•  Plan already assumes 65% → 60%. Each extra 1 pt lost costs ≈$28k/month by M12.</a:t>
+              <a:t>•  The plan already assumes 65% → 60%. Each extra point lost costs ≈$28k/month by M12.</a:t>
             </a:r>
           </a:p>
           <a:p>
@@ -12900,7 +12519,7 @@
               </a:spcAft>
             </a:pPr>
             <a:r>
-              <a:rPr sz="1050" b="0" i="0">
+              <a:rPr sz="1019" b="0" i="0">
                 <a:solidFill>
                   <a:srgbClr val="111827"/>
                 </a:solidFill>
@@ -12909,22 +12528,22 @@
               <a:t>•  </a:t>
             </a:r>
             <a:r>
-              <a:rPr sz="1050" b="1" i="0">
+              <a:rPr sz="1019" b="1" i="0">
                 <a:solidFill>
                   <a:srgbClr val="111827"/>
                 </a:solidFill>
                 <a:latin typeface="Arial"/>
               </a:rPr>
-              <a:t>KPIs:</a:t>
-            </a:r>
-            <a:r>
-              <a:rPr sz="1050" b="0" i="0">
+              <a:t>Watch:</a:t>
+            </a:r>
+            <a:r>
+              <a:rPr sz="1019" b="0" i="0">
                 <a:solidFill>
                   <a:srgbClr val="111827"/>
                 </a:solidFill>
                 <a:latin typeface="Arial"/>
               </a:rPr>
-              <a:t> monthly GM %, COGS per active student, cost per finished video, hosting per user.</a:t>
+              <a:t> monthly gross margin %, cost per customer, cost per finished video.</a:t>
             </a:r>
           </a:p>
           <a:p>
@@ -12934,7 +12553,7 @@
               </a:spcAft>
             </a:pPr>
             <a:r>
-              <a:rPr sz="1050" b="0" i="0">
+              <a:rPr sz="1019" b="0" i="0">
                 <a:solidFill>
                   <a:srgbClr val="111827"/>
                 </a:solidFill>
@@ -12943,22 +12562,22 @@
               <a:t>•  </a:t>
             </a:r>
             <a:r>
-              <a:rPr sz="1050" b="1" i="0">
+              <a:rPr sz="1019" b="1" i="0">
                 <a:solidFill>
                   <a:srgbClr val="111827"/>
                 </a:solidFill>
                 <a:latin typeface="Arial"/>
               </a:rPr>
-              <a:t>Trigger:</a:t>
-            </a:r>
-            <a:r>
-              <a:rPr sz="1050" b="0" i="0">
+              <a:t>Act if:</a:t>
+            </a:r>
+            <a:r>
+              <a:rPr sz="1019" b="0" i="0">
                 <a:solidFill>
                   <a:srgbClr val="111827"/>
                 </a:solidFill>
                 <a:latin typeface="Arial"/>
               </a:rPr>
-              <a:t> GM below plan for 2 months running → cost review: vendor renegotiation, AI tooling for content, pricing.</a:t>
+              <a:t> margin is below plan 2 months in a row → cost review (suppliers, AI tooling for content, pricing).</a:t>
             </a:r>
           </a:p>
         </p:txBody>
@@ -13128,7 +12747,7 @@
                 </a:solidFill>
                 <a:latin typeface="Arial"/>
               </a:rPr>
-              <a:t>Collections and quality of growth</a:t>
+              <a:t>Growth and cash collection</a:t>
             </a:r>
           </a:p>
         </p:txBody>
@@ -13161,13 +12780,13 @@
               </a:spcAft>
             </a:pPr>
             <a:r>
-              <a:rPr sz="1050" b="0" i="0">
+              <a:rPr sz="1019" b="0" i="0">
                 <a:solidFill>
                   <a:srgbClr val="111827"/>
                 </a:solidFill>
                 <a:latin typeface="Arial"/>
               </a:rPr>
-              <a:t>•  Receivables grow by $2.0M even at 45 days. If schools slip to 90 days, receivables double: ≈$4.3M more cash tied up at M12 revenue.</a:t>
+              <a:t>•  6% monthly growth compounds; small slips add up. The model also assumes schools pay in the month invoiced: a 30-day delay would tie up about one month of revenue ($1.5M–$2.8M).</a:t>
             </a:r>
           </a:p>
           <a:p>
@@ -13177,7 +12796,7 @@
               </a:spcAft>
             </a:pPr>
             <a:r>
-              <a:rPr sz="1050" b="0" i="0">
+              <a:rPr sz="1019" b="0" i="0">
                 <a:solidFill>
                   <a:srgbClr val="111827"/>
                 </a:solidFill>
@@ -13186,22 +12805,22 @@
               <a:t>•  </a:t>
             </a:r>
             <a:r>
-              <a:rPr sz="1050" b="1" i="0">
+              <a:rPr sz="1019" b="1" i="0">
                 <a:solidFill>
                   <a:srgbClr val="111827"/>
                 </a:solidFill>
                 <a:latin typeface="Arial"/>
               </a:rPr>
-              <a:t>KPIs:</a:t>
-            </a:r>
-            <a:r>
-              <a:rPr sz="1050" b="0" i="0">
+              <a:t>Watch:</a:t>
+            </a:r>
+            <a:r>
+              <a:rPr sz="1019" b="0" i="0">
                 <a:solidFill>
                   <a:srgbClr val="111827"/>
                 </a:solidFill>
                 <a:latin typeface="Arial"/>
               </a:rPr>
-              <a:t> DSO, % of AR over 60 days, MoM growth, pipeline coverage (3× next quarter), logo churn.</a:t>
+              <a:t> monthly growth, sales pipeline, customer churn, days to collect payment.</a:t>
             </a:r>
           </a:p>
           <a:p>
@@ -13211,7 +12830,7 @@
               </a:spcAft>
             </a:pPr>
             <a:r>
-              <a:rPr sz="1050" b="0" i="0">
+              <a:rPr sz="1019" b="0" i="0">
                 <a:solidFill>
                   <a:srgbClr val="111827"/>
                 </a:solidFill>
@@ -13220,22 +12839,22 @@
               <a:t>•  </a:t>
             </a:r>
             <a:r>
-              <a:rPr sz="1050" b="1" i="0">
+              <a:rPr sz="1019" b="1" i="0">
                 <a:solidFill>
                   <a:srgbClr val="111827"/>
                 </a:solidFill>
                 <a:latin typeface="Arial"/>
               </a:rPr>
-              <a:t>Trigger:</a:t>
-            </a:r>
-            <a:r>
-              <a:rPr sz="1050" b="0" i="0">
+              <a:t>Act if:</a:t>
+            </a:r>
+            <a:r>
+              <a:rPr sz="1019" b="0" i="0">
                 <a:solidFill>
                   <a:srgbClr val="111827"/>
                 </a:solidFill>
                 <a:latin typeface="Arial"/>
               </a:rPr>
-              <a:t> DSO above 60 days, or growth below 4% for 2 months → pause M5–M6 hires and activate the standby line.</a:t>
+              <a:t> growth is below 4% for 2 months → pause the M5–M6 hires and review the plan.</a:t>
             </a:r>
           </a:p>
         </p:txBody>
@@ -13274,7 +12893,7 @@
                 </a:solidFill>
                 <a:latin typeface="Arial"/>
               </a:rPr>
-              <a:t>Also validate before the board: the case cost base excludes Luca's existing team (see Stress).</a:t>
+              <a:t>Note: the case cost base covers only the 25 new hires, overhead and G&amp;A.</a:t>
             </a:r>
           </a:p>
         </p:txBody>

</xml_diff>

<commit_message>
Add cost-base footnote to loan slide
Co-authored-by: JoaoTavarees <JoaoTavarees@users.noreply.github.com>
</commit_message>
<xml_diff>
--- a/luca_chief_of_staff_case/deliverables/Luca_Step2_Financial_Operations_Summary.pptx
+++ b/luca_chief_of_staff_case/deliverables/Luca_Step2_Financial_Operations_Summary.pptx
@@ -12314,7 +12314,7 @@
         <p:spPr>
           <a:xfrm>
             <a:off x="6492240" y="1828800"/>
-            <a:ext cx="5257800" cy="2103120"/>
+            <a:ext cx="5257800" cy="1965960"/>
           </a:xfrm>
           <a:prstGeom prst="roundRect">
             <a:avLst>
@@ -12483,8 +12483,8 @@
         </p:nvSpPr>
         <p:spPr>
           <a:xfrm>
-            <a:off x="6675120" y="2450592"/>
-            <a:ext cx="4983480" cy="1463040"/>
+            <a:off x="6675120" y="2414016"/>
+            <a:ext cx="4983480" cy="1371600"/>
           </a:xfrm>
           <a:prstGeom prst="rect">
             <a:avLst/>
@@ -12499,11 +12499,11 @@
           <a:p>
             <a:pPr algn="l">
               <a:spcAft>
-                <a:spcPts val="500"/>
+                <a:spcPts val="400"/>
               </a:spcAft>
             </a:pPr>
             <a:r>
-              <a:rPr sz="1019" b="0" i="0">
+              <a:rPr sz="1000" b="0" i="0">
                 <a:solidFill>
                   <a:srgbClr val="111827"/>
                 </a:solidFill>
@@ -12515,11 +12515,11 @@
           <a:p>
             <a:pPr algn="l">
               <a:spcAft>
-                <a:spcPts val="500"/>
+                <a:spcPts val="400"/>
               </a:spcAft>
             </a:pPr>
             <a:r>
-              <a:rPr sz="1019" b="0" i="0">
+              <a:rPr sz="1000" b="0" i="0">
                 <a:solidFill>
                   <a:srgbClr val="111827"/>
                 </a:solidFill>
@@ -12528,7 +12528,7 @@
               <a:t>•  </a:t>
             </a:r>
             <a:r>
-              <a:rPr sz="1019" b="1" i="0">
+              <a:rPr sz="1000" b="1" i="0">
                 <a:solidFill>
                   <a:srgbClr val="111827"/>
                 </a:solidFill>
@@ -12537,7 +12537,7 @@
               <a:t>Watch:</a:t>
             </a:r>
             <a:r>
-              <a:rPr sz="1019" b="0" i="0">
+              <a:rPr sz="1000" b="0" i="0">
                 <a:solidFill>
                   <a:srgbClr val="111827"/>
                 </a:solidFill>
@@ -12549,11 +12549,11 @@
           <a:p>
             <a:pPr algn="l">
               <a:spcAft>
-                <a:spcPts val="500"/>
+                <a:spcPts val="400"/>
               </a:spcAft>
             </a:pPr>
             <a:r>
-              <a:rPr sz="1019" b="0" i="0">
+              <a:rPr sz="1000" b="0" i="0">
                 <a:solidFill>
                   <a:srgbClr val="111827"/>
                 </a:solidFill>
@@ -12562,7 +12562,7 @@
               <a:t>•  </a:t>
             </a:r>
             <a:r>
-              <a:rPr sz="1019" b="1" i="0">
+              <a:rPr sz="1000" b="1" i="0">
                 <a:solidFill>
                   <a:srgbClr val="111827"/>
                 </a:solidFill>
@@ -12571,7 +12571,7 @@
               <a:t>Act if:</a:t>
             </a:r>
             <a:r>
-              <a:rPr sz="1019" b="0" i="0">
+              <a:rPr sz="1000" b="0" i="0">
                 <a:solidFill>
                   <a:srgbClr val="111827"/>
                 </a:solidFill>
@@ -12590,8 +12590,8 @@
         </p:nvSpPr>
         <p:spPr>
           <a:xfrm>
-            <a:off x="6492240" y="4069080"/>
-            <a:ext cx="5257800" cy="2103120"/>
+            <a:off x="6492240" y="3886200"/>
+            <a:ext cx="5257800" cy="1965960"/>
           </a:xfrm>
           <a:prstGeom prst="roundRect">
             <a:avLst>
@@ -12636,7 +12636,7 @@
         </p:nvSpPr>
         <p:spPr>
           <a:xfrm>
-            <a:off x="6629400" y="4206240"/>
+            <a:off x="6629400" y="4023360"/>
             <a:ext cx="384048" cy="384048"/>
           </a:xfrm>
           <a:prstGeom prst="roundRect">
@@ -12682,7 +12682,7 @@
         </p:nvSpPr>
         <p:spPr>
           <a:xfrm>
-            <a:off x="6629400" y="4206240"/>
+            <a:off x="6629400" y="4023360"/>
             <a:ext cx="384048" cy="384048"/>
           </a:xfrm>
           <a:prstGeom prst="rect">
@@ -12721,7 +12721,7 @@
         </p:nvSpPr>
         <p:spPr>
           <a:xfrm>
-            <a:off x="7132320" y="4178808"/>
+            <a:off x="7132320" y="3995928"/>
             <a:ext cx="4526280" cy="457200"/>
           </a:xfrm>
           <a:prstGeom prst="rect">
@@ -12760,115 +12760,8 @@
         </p:nvSpPr>
         <p:spPr>
           <a:xfrm>
-            <a:off x="6675120" y="4690872"/>
-            <a:ext cx="4983480" cy="1463040"/>
-          </a:xfrm>
-          <a:prstGeom prst="rect">
-            <a:avLst/>
-          </a:prstGeom>
-          <a:noFill/>
-        </p:spPr>
-        <p:txBody>
-          <a:bodyPr wrap="square" anchor="t" lIns="45720" rIns="45720">
-            <a:spAutoFit/>
-          </a:bodyPr>
-          <a:lstStyle/>
-          <a:p>
-            <a:pPr algn="l">
-              <a:spcAft>
-                <a:spcPts val="500"/>
-              </a:spcAft>
-            </a:pPr>
-            <a:r>
-              <a:rPr sz="1019" b="0" i="0">
-                <a:solidFill>
-                  <a:srgbClr val="111827"/>
-                </a:solidFill>
-                <a:latin typeface="Arial"/>
-              </a:rPr>
-              <a:t>•  6% monthly growth compounds; small slips add up. The model also assumes schools pay in the month invoiced: a 30-day delay would tie up about one month of revenue ($1.5M–$2.8M).</a:t>
-            </a:r>
-          </a:p>
-          <a:p>
-            <a:pPr algn="l">
-              <a:spcAft>
-                <a:spcPts val="500"/>
-              </a:spcAft>
-            </a:pPr>
-            <a:r>
-              <a:rPr sz="1019" b="0" i="0">
-                <a:solidFill>
-                  <a:srgbClr val="111827"/>
-                </a:solidFill>
-                <a:latin typeface="Arial"/>
-              </a:rPr>
-              <a:t>•  </a:t>
-            </a:r>
-            <a:r>
-              <a:rPr sz="1019" b="1" i="0">
-                <a:solidFill>
-                  <a:srgbClr val="111827"/>
-                </a:solidFill>
-                <a:latin typeface="Arial"/>
-              </a:rPr>
-              <a:t>Watch:</a:t>
-            </a:r>
-            <a:r>
-              <a:rPr sz="1019" b="0" i="0">
-                <a:solidFill>
-                  <a:srgbClr val="111827"/>
-                </a:solidFill>
-                <a:latin typeface="Arial"/>
-              </a:rPr>
-              <a:t> monthly growth, sales pipeline, customer churn, days to collect payment.</a:t>
-            </a:r>
-          </a:p>
-          <a:p>
-            <a:pPr algn="l">
-              <a:spcAft>
-                <a:spcPts val="500"/>
-              </a:spcAft>
-            </a:pPr>
-            <a:r>
-              <a:rPr sz="1019" b="0" i="0">
-                <a:solidFill>
-                  <a:srgbClr val="111827"/>
-                </a:solidFill>
-                <a:latin typeface="Arial"/>
-              </a:rPr>
-              <a:t>•  </a:t>
-            </a:r>
-            <a:r>
-              <a:rPr sz="1019" b="1" i="0">
-                <a:solidFill>
-                  <a:srgbClr val="111827"/>
-                </a:solidFill>
-                <a:latin typeface="Arial"/>
-              </a:rPr>
-              <a:t>Act if:</a:t>
-            </a:r>
-            <a:r>
-              <a:rPr sz="1019" b="0" i="0">
-                <a:solidFill>
-                  <a:srgbClr val="111827"/>
-                </a:solidFill>
-                <a:latin typeface="Arial"/>
-              </a:rPr>
-              <a:t> growth is below 4% for 2 months → pause the M5–M6 hires and review the plan.</a:t>
-            </a:r>
-          </a:p>
-        </p:txBody>
-      </p:sp>
-      <p:sp>
-        <p:nvSpPr>
-          <p:cNvPr id="26" name="TextBox 25"/>
-          <p:cNvSpPr txBox="1"/>
-          <p:nvPr/>
-        </p:nvSpPr>
-        <p:spPr>
-          <a:xfrm>
-            <a:off x="6492240" y="6291072"/>
-            <a:ext cx="5257800" cy="228600"/>
+            <a:off x="6675120" y="4471416"/>
+            <a:ext cx="4983480" cy="1371600"/>
           </a:xfrm>
           <a:prstGeom prst="rect">
             <a:avLst/>
@@ -12887,13 +12780,120 @@
               </a:spcAft>
             </a:pPr>
             <a:r>
+              <a:rPr sz="1000" b="0" i="0">
+                <a:solidFill>
+                  <a:srgbClr val="111827"/>
+                </a:solidFill>
+                <a:latin typeface="Arial"/>
+              </a:rPr>
+              <a:t>•  6% monthly growth compounds; small slips add up. The model also assumes schools pay in the month invoiced: a 30-day delay would tie up about one month of revenue ($1.5M–$2.8M).</a:t>
+            </a:r>
+          </a:p>
+          <a:p>
+            <a:pPr algn="l">
+              <a:spcAft>
+                <a:spcPts val="400"/>
+              </a:spcAft>
+            </a:pPr>
+            <a:r>
+              <a:rPr sz="1000" b="0" i="0">
+                <a:solidFill>
+                  <a:srgbClr val="111827"/>
+                </a:solidFill>
+                <a:latin typeface="Arial"/>
+              </a:rPr>
+              <a:t>•  </a:t>
+            </a:r>
+            <a:r>
+              <a:rPr sz="1000" b="1" i="0">
+                <a:solidFill>
+                  <a:srgbClr val="111827"/>
+                </a:solidFill>
+                <a:latin typeface="Arial"/>
+              </a:rPr>
+              <a:t>Watch:</a:t>
+            </a:r>
+            <a:r>
+              <a:rPr sz="1000" b="0" i="0">
+                <a:solidFill>
+                  <a:srgbClr val="111827"/>
+                </a:solidFill>
+                <a:latin typeface="Arial"/>
+              </a:rPr>
+              <a:t> monthly growth, sales pipeline, customer churn, days to collect payment.</a:t>
+            </a:r>
+          </a:p>
+          <a:p>
+            <a:pPr algn="l">
+              <a:spcAft>
+                <a:spcPts val="400"/>
+              </a:spcAft>
+            </a:pPr>
+            <a:r>
+              <a:rPr sz="1000" b="0" i="0">
+                <a:solidFill>
+                  <a:srgbClr val="111827"/>
+                </a:solidFill>
+                <a:latin typeface="Arial"/>
+              </a:rPr>
+              <a:t>•  </a:t>
+            </a:r>
+            <a:r>
+              <a:rPr sz="1000" b="1" i="0">
+                <a:solidFill>
+                  <a:srgbClr val="111827"/>
+                </a:solidFill>
+                <a:latin typeface="Arial"/>
+              </a:rPr>
+              <a:t>Act if:</a:t>
+            </a:r>
+            <a:r>
+              <a:rPr sz="1000" b="0" i="0">
+                <a:solidFill>
+                  <a:srgbClr val="111827"/>
+                </a:solidFill>
+                <a:latin typeface="Arial"/>
+              </a:rPr>
+              <a:t> growth is below 4% for 2 months → pause the M5–M6 hires and review the plan.</a:t>
+            </a:r>
+          </a:p>
+        </p:txBody>
+      </p:sp>
+      <p:sp>
+        <p:nvSpPr>
+          <p:cNvPr id="26" name="TextBox 25"/>
+          <p:cNvSpPr txBox="1"/>
+          <p:nvPr/>
+        </p:nvSpPr>
+        <p:spPr>
+          <a:xfrm>
+            <a:off x="6492240" y="5897880"/>
+            <a:ext cx="5257800" cy="548640"/>
+          </a:xfrm>
+          <a:prstGeom prst="rect">
+            <a:avLst/>
+          </a:prstGeom>
+          <a:noFill/>
+        </p:spPr>
+        <p:txBody>
+          <a:bodyPr wrap="square" anchor="t" lIns="45720" rIns="45720">
+            <a:spAutoFit/>
+          </a:bodyPr>
+          <a:lstStyle/>
+          <a:p>
+            <a:pPr algn="l">
+              <a:spcAft>
+                <a:spcPts val="400"/>
+              </a:spcAft>
+            </a:pPr>
+            <a:r>
               <a:rPr sz="850" b="0" i="1">
                 <a:solidFill>
                   <a:srgbClr val="6B7280"/>
                 </a:solidFill>
                 <a:latin typeface="Arial"/>
               </a:rPr>
-              <a:t>Note: the case cost base covers only the 25 new hires, overhead and G&amp;A.</a:t>
+              <a:t>Note: the case cost base covers only the 25 new hires, overhead and G&amp;A, so Luca generates cash every month and runway is not a constraint. Next step before the board: add Luca's existing cost base (current team, marketing, technology) to the model. That is where runway and the loan decision become relevant.</a:t>
             </a:r>
           </a:p>
         </p:txBody>

</xml_diff>